<commit_message>
Added globals code and updated L10 and L11
</commit_message>
<xml_diff>
--- a/Slides/L11_Input-and-Output.pptx
+++ b/Slides/L11_Input-and-Output.pptx
@@ -803,7 +803,12 @@
             <p:ph type="sldImg"/>
           </p:nvPr>
         </p:nvSpPr>
-        <p:spPr/>
+        <p:spPr>
+          <a:xfrm>
+            <a:off x="0" y="763588"/>
+            <a:ext cx="0" cy="0"/>
+          </a:xfrm>
+        </p:spPr>
       </p:sp>
       <p:sp>
         <p:nvSpPr>
@@ -1478,7 +1483,12 @@
             <p:ph type="sldImg"/>
           </p:nvPr>
         </p:nvSpPr>
-        <p:spPr/>
+        <p:spPr>
+          <a:xfrm>
+            <a:off x="0" y="763588"/>
+            <a:ext cx="0" cy="0"/>
+          </a:xfrm>
+        </p:spPr>
       </p:sp>
       <p:sp>
         <p:nvSpPr>
@@ -3128,7 +3138,12 @@
             <p:ph type="sldImg"/>
           </p:nvPr>
         </p:nvSpPr>
-        <p:spPr/>
+        <p:spPr>
+          <a:xfrm>
+            <a:off x="0" y="763588"/>
+            <a:ext cx="0" cy="0"/>
+          </a:xfrm>
+        </p:spPr>
       </p:sp>
       <p:sp>
         <p:nvSpPr>
@@ -43855,7 +43870,7 @@
         <p:spPr>
           <a:xfrm>
             <a:off x="580041" y="1949942"/>
-            <a:ext cx="8135334" cy="5593858"/>
+            <a:ext cx="8135334" cy="2785378"/>
           </a:xfrm>
           <a:prstGeom prst="rect">
             <a:avLst/>
@@ -43874,10 +43889,16 @@
               </a:tabLst>
             </a:pPr>
             <a:r>
-              <a:rPr sz="2500" b="0">
+              <a:rPr sz="2500" b="0" dirty="0" err="1">
                 <a:latin typeface="Cambria"/>
               </a:rPr>
-              <a:t>printf ( "%d\n", 3.5 ) ;	prints garbage</a:t>
+              <a:t>printf</a:t>
+            </a:r>
+            <a:r>
+              <a:rPr sz="2500" b="0" dirty="0">
+                <a:latin typeface="Cambria"/>
+              </a:rPr>
+              <a:t> ( "%d\n", 3.5 ) ;	prints garbage</a:t>
             </a:r>
           </a:p>
           <a:p>
@@ -43887,10 +43908,16 @@
               </a:tabLst>
             </a:pPr>
             <a:r>
-              <a:rPr sz="2500" b="0">
+              <a:rPr sz="2500" b="0" dirty="0" err="1">
                 <a:latin typeface="Cambria"/>
               </a:rPr>
-              <a:t>printf ( "%s\n", 42 ) ;	may crash</a:t>
+              <a:t>printf</a:t>
+            </a:r>
+            <a:r>
+              <a:rPr sz="2500" b="0" dirty="0">
+                <a:latin typeface="Cambria"/>
+              </a:rPr>
+              <a:t> ( "%s\n", 42 ) ;	may crash</a:t>
             </a:r>
           </a:p>
           <a:p>
@@ -43900,7 +43927,7 @@
               </a:tabLst>
             </a:pPr>
             <a:r>
-              <a:rPr sz="2500">
+              <a:rPr sz="2500" dirty="0">
                 <a:latin typeface="Cambria"/>
               </a:rPr>
               <a:t> </a:t>
@@ -43913,10 +43940,16 @@
               </a:tabLst>
             </a:pPr>
             <a:r>
-              <a:rPr sz="2500" b="0">
+              <a:rPr sz="2500" b="0" dirty="0" err="1">
                 <a:latin typeface="Cambria"/>
               </a:rPr>
-              <a:t>printf trusts the format string completely</a:t>
+              <a:t>printf</a:t>
+            </a:r>
+            <a:r>
+              <a:rPr sz="2500" b="0" dirty="0">
+                <a:latin typeface="Cambria"/>
+              </a:rPr>
+              <a:t> trusts the format string completely</a:t>
             </a:r>
           </a:p>
           <a:p>
@@ -43926,7 +43959,7 @@
               </a:tabLst>
             </a:pPr>
             <a:r>
-              <a:rPr sz="2500">
+              <a:rPr sz="2500" dirty="0">
                 <a:latin typeface="Cambria"/>
               </a:rPr>
               <a:t> </a:t>
@@ -43939,35 +43972,46 @@
               </a:tabLst>
             </a:pPr>
             <a:r>
-              <a:rPr sz="2500" b="0">
+              <a:rPr sz="2500" b="0" dirty="0">
                 <a:latin typeface="Cambria"/>
               </a:rPr>
               <a:t>Compile with  </a:t>
             </a:r>
             <a:r>
-              <a:rPr sz="2500" b="1">
+              <a:rPr sz="2500" b="1" dirty="0">
                 <a:latin typeface="Cambria"/>
               </a:rPr>
               <a:t>-Wall</a:t>
             </a:r>
             <a:r>
-              <a:rPr sz="2500" b="0">
+              <a:rPr sz="2500" b="0" dirty="0">
                 <a:latin typeface="Cambria"/>
               </a:rPr>
-              <a:t>  and the compiler</a:t>
-            </a:r>
-          </a:p>
-          <a:p>
-            <a:pPr>
-              <a:tabLst>
-                <a:tab pos="4023360" algn="l"/>
-              </a:tabLst>
-            </a:pPr>
-            <a:r>
-              <a:rPr sz="2500" b="0">
+              <a:t>  and the </a:t>
+            </a:r>
+            <a:r>
+              <a:rPr sz="2500" b="0" dirty="0" smtClean="0">
                 <a:latin typeface="Cambria"/>
               </a:rPr>
-              <a:t>checks every format for you</a:t>
+              <a:t>compiler</a:t>
+            </a:r>
+            <a:r>
+              <a:rPr lang="en-US" sz="2500" b="0" dirty="0" smtClean="0">
+                <a:latin typeface="Cambria"/>
+              </a:rPr>
+              <a:t> </a:t>
+            </a:r>
+            <a:r>
+              <a:rPr sz="2500" b="0" dirty="0" smtClean="0">
+                <a:latin typeface="Cambria"/>
+              </a:rPr>
+              <a:t>checks </a:t>
+            </a:r>
+            <a:r>
+              <a:rPr sz="2500" b="0" dirty="0">
+                <a:latin typeface="Cambria"/>
+              </a:rPr>
+              <a:t>every format for you</a:t>
             </a:r>
           </a:p>
         </p:txBody>
@@ -46463,7 +46507,7 @@
         <p:spPr>
           <a:xfrm>
             <a:off x="580041" y="1949942"/>
-            <a:ext cx="8135334" cy="5593858"/>
+            <a:ext cx="8135334" cy="3108543"/>
           </a:xfrm>
           <a:prstGeom prst="rect">
             <a:avLst/>
@@ -46485,7 +46529,7 @@
               </a:tabLst>
             </a:pPr>
             <a:r>
-              <a:rPr sz="2800" b="0">
+              <a:rPr sz="2800" b="0" dirty="0">
                 <a:latin typeface="Cambria"/>
               </a:rPr>
               <a:t>We can store, compute, repeat, and organize</a:t>
@@ -46501,7 +46545,7 @@
               </a:tabLst>
             </a:pPr>
             <a:r>
-              <a:rPr sz="2800">
+              <a:rPr sz="2800" dirty="0">
                 <a:latin typeface="Cambria"/>
               </a:rPr>
               <a:t> </a:t>
@@ -46517,19 +46561,19 @@
               </a:tabLst>
             </a:pPr>
             <a:r>
-              <a:rPr sz="2800" b="0">
+              <a:rPr sz="2800" b="0" dirty="0">
                 <a:latin typeface="Cambria"/>
               </a:rPr>
               <a:t>But every result has stayed </a:t>
             </a:r>
             <a:r>
-              <a:rPr sz="2800" b="1">
+              <a:rPr sz="2800" b="1" dirty="0">
                 <a:latin typeface="Cambria"/>
               </a:rPr>
               <a:t>inside</a:t>
             </a:r>
             <a:r>
-              <a:rPr sz="2800" b="0">
+              <a:rPr sz="2800" b="0" dirty="0">
                 <a:latin typeface="Cambria"/>
               </a:rPr>
               <a:t> the program</a:t>
@@ -46545,7 +46589,7 @@
               </a:tabLst>
             </a:pPr>
             <a:r>
-              <a:rPr sz="2800">
+              <a:rPr sz="2800" dirty="0">
                 <a:latin typeface="Cambria"/>
               </a:rPr>
               <a:t> </a:t>
@@ -46561,10 +46605,34 @@
               </a:tabLst>
             </a:pPr>
             <a:r>
-              <a:rPr sz="2800" b="0">
+              <a:rPr sz="2800" b="0" dirty="0">
                 <a:latin typeface="Cambria"/>
               </a:rPr>
-              <a:t>So far the only way to see it has been</a:t>
+              <a:t>So far the only way to see it has </a:t>
+            </a:r>
+            <a:r>
+              <a:rPr sz="2800" b="0" dirty="0" smtClean="0">
+                <a:latin typeface="Cambria"/>
+              </a:rPr>
+              <a:t>been</a:t>
+            </a:r>
+            <a:r>
+              <a:rPr lang="en-US" sz="2800" b="0" dirty="0" smtClean="0">
+                <a:latin typeface="Cambria"/>
+              </a:rPr>
+              <a:t> </a:t>
+            </a:r>
+            <a:r>
+              <a:rPr sz="2800" b="0" dirty="0" smtClean="0">
+                <a:latin typeface="Cambria"/>
+              </a:rPr>
+              <a:t>the </a:t>
+            </a:r>
+            <a:r>
+              <a:rPr sz="2800" b="1" dirty="0">
+                <a:latin typeface="Cambria"/>
+              </a:rPr>
+              <a:t>debugger</a:t>
             </a:r>
           </a:p>
           <a:p>
@@ -46577,16 +46645,10 @@
               </a:tabLst>
             </a:pPr>
             <a:r>
-              <a:rPr sz="2800" b="0">
+              <a:rPr sz="2800" dirty="0">
                 <a:latin typeface="Cambria"/>
               </a:rPr>
-              <a:t>the </a:t>
-            </a:r>
-            <a:r>
-              <a:rPr sz="2800" b="1">
-                <a:latin typeface="Cambria"/>
-              </a:rPr>
-              <a:t>debugger</a:t>
+              <a:t> </a:t>
             </a:r>
           </a:p>
           <a:p>
@@ -46599,23 +46661,7 @@
               </a:tabLst>
             </a:pPr>
             <a:r>
-              <a:rPr sz="2800">
-                <a:latin typeface="Cambria"/>
-              </a:rPr>
-              <a:t> </a:t>
-            </a:r>
-          </a:p>
-          <a:p>
-            <a:pPr>
-              <a:tabLst>
-                <a:tab pos="548640" algn="l"/>
-                <a:tab pos="1097280" algn="l"/>
-                <a:tab pos="1645920" algn="l"/>
-                <a:tab pos="2194560" algn="l"/>
-              </a:tabLst>
-            </a:pPr>
-            <a:r>
-              <a:rPr sz="2800" b="0">
+              <a:rPr sz="2800" b="0" dirty="0">
                 <a:latin typeface="Cambria"/>
               </a:rPr>
               <a:t>Today:  talking to the outside world</a:t>
@@ -53658,7 +53704,7 @@
         <p:spPr>
           <a:xfrm>
             <a:off x="580041" y="1949942"/>
-            <a:ext cx="8135334" cy="5593858"/>
+            <a:ext cx="8135334" cy="3293209"/>
           </a:xfrm>
           <a:prstGeom prst="rect">
             <a:avLst/>
@@ -53679,22 +53725,46 @@
               </a:tabLst>
             </a:pPr>
             <a:r>
-              <a:rPr sz="2600" b="0">
+              <a:rPr sz="2600" b="0" dirty="0">
                 <a:latin typeface="Cambria"/>
               </a:rPr>
               <a:t>A </a:t>
             </a:r>
             <a:r>
-              <a:rPr sz="2600" b="1">
+              <a:rPr sz="2600" b="1" dirty="0">
                 <a:latin typeface="Cambria"/>
               </a:rPr>
               <a:t>stream</a:t>
             </a:r>
             <a:r>
-              <a:rPr sz="2600" b="0">
+              <a:rPr sz="2600" b="0" dirty="0">
                 <a:latin typeface="Cambria"/>
               </a:rPr>
-              <a:t> is a sequence of bytes flowing</a:t>
+              <a:t> is a sequence of bytes </a:t>
+            </a:r>
+            <a:r>
+              <a:rPr sz="2600" b="0" dirty="0" smtClean="0">
+                <a:latin typeface="Cambria"/>
+              </a:rPr>
+              <a:t>flowing</a:t>
+            </a:r>
+            <a:r>
+              <a:rPr lang="en-US" sz="2600" b="0" dirty="0" smtClean="0">
+                <a:latin typeface="Cambria"/>
+              </a:rPr>
+              <a:t> </a:t>
+            </a:r>
+            <a:r>
+              <a:rPr sz="2600" b="0" dirty="0" smtClean="0">
+                <a:latin typeface="Cambria"/>
+              </a:rPr>
+              <a:t>into </a:t>
+            </a:r>
+            <a:r>
+              <a:rPr sz="2600" b="0" dirty="0">
+                <a:latin typeface="Cambria"/>
+              </a:rPr>
+              <a:t>or out of a program</a:t>
             </a:r>
           </a:p>
           <a:p>
@@ -53706,10 +53776,10 @@
               </a:tabLst>
             </a:pPr>
             <a:r>
-              <a:rPr sz="2600" b="0">
+              <a:rPr sz="2600" dirty="0">
                 <a:latin typeface="Cambria"/>
               </a:rPr>
-              <a:t>into or out of a program</a:t>
+              <a:t> </a:t>
             </a:r>
           </a:p>
           <a:p>
@@ -53721,10 +53791,22 @@
               </a:tabLst>
             </a:pPr>
             <a:r>
-              <a:rPr sz="2600">
+              <a:rPr sz="2600" b="0" dirty="0">
                 <a:latin typeface="Cambria"/>
               </a:rPr>
-              <a:t> </a:t>
+              <a:t>Every program starts with </a:t>
+            </a:r>
+            <a:r>
+              <a:rPr sz="2600" b="1" dirty="0">
+                <a:latin typeface="Cambria"/>
+              </a:rPr>
+              <a:t>three</a:t>
+            </a:r>
+            <a:r>
+              <a:rPr sz="2600" b="0" dirty="0">
+                <a:latin typeface="Cambria"/>
+              </a:rPr>
+              <a:t>:</a:t>
             </a:r>
           </a:p>
           <a:p>
@@ -53736,22 +53818,10 @@
               </a:tabLst>
             </a:pPr>
             <a:r>
-              <a:rPr sz="2600" b="0">
+              <a:rPr sz="2600" dirty="0">
                 <a:latin typeface="Cambria"/>
               </a:rPr>
-              <a:t>Every program starts with </a:t>
-            </a:r>
-            <a:r>
-              <a:rPr sz="2600" b="1">
-                <a:latin typeface="Cambria"/>
-              </a:rPr>
-              <a:t>three</a:t>
-            </a:r>
-            <a:r>
-              <a:rPr sz="2600" b="0">
-                <a:latin typeface="Cambria"/>
-              </a:rPr>
-              <a:t>:</a:t>
+              <a:t> </a:t>
             </a:r>
           </a:p>
           <a:p>
@@ -53763,10 +53833,22 @@
               </a:tabLst>
             </a:pPr>
             <a:r>
-              <a:rPr sz="2600">
+              <a:rPr sz="2600" b="0" dirty="0">
                 <a:latin typeface="Cambria"/>
               </a:rPr>
-              <a:t> </a:t>
+              <a:t>	</a:t>
+            </a:r>
+            <a:r>
+              <a:rPr sz="2600" b="0" dirty="0" err="1">
+                <a:latin typeface="Cambria"/>
+              </a:rPr>
+              <a:t>stdin</a:t>
+            </a:r>
+            <a:r>
+              <a:rPr sz="2600" b="0" dirty="0">
+                <a:latin typeface="Cambria"/>
+              </a:rPr>
+              <a:t>	0	standard input</a:t>
             </a:r>
           </a:p>
           <a:p>
@@ -53778,10 +53860,22 @@
               </a:tabLst>
             </a:pPr>
             <a:r>
-              <a:rPr sz="2600" b="0">
+              <a:rPr sz="2600" b="0" dirty="0">
                 <a:latin typeface="Cambria"/>
               </a:rPr>
-              <a:t>	stdin	0	standard input</a:t>
+              <a:t>	</a:t>
+            </a:r>
+            <a:r>
+              <a:rPr sz="2600" b="0" dirty="0" err="1">
+                <a:latin typeface="Cambria"/>
+              </a:rPr>
+              <a:t>stdout</a:t>
+            </a:r>
+            <a:r>
+              <a:rPr sz="2600" b="0" dirty="0">
+                <a:latin typeface="Cambria"/>
+              </a:rPr>
+              <a:t>	1	standard output</a:t>
             </a:r>
           </a:p>
           <a:p>
@@ -53793,25 +53887,22 @@
               </a:tabLst>
             </a:pPr>
             <a:r>
-              <a:rPr sz="2600" b="0">
+              <a:rPr sz="2600" b="0" dirty="0">
                 <a:latin typeface="Cambria"/>
               </a:rPr>
-              <a:t>	stdout	1	standard output</a:t>
-            </a:r>
-          </a:p>
-          <a:p>
-            <a:pPr>
-              <a:tabLst>
-                <a:tab pos="548640" algn="l"/>
-                <a:tab pos="2011680" algn="l"/>
-                <a:tab pos="2743200" algn="l"/>
-              </a:tabLst>
-            </a:pPr>
-            <a:r>
-              <a:rPr sz="2600" b="0">
+              <a:t>	</a:t>
+            </a:r>
+            <a:r>
+              <a:rPr sz="2600" b="0" dirty="0" err="1">
                 <a:latin typeface="Cambria"/>
               </a:rPr>
-              <a:t>	stderr	2	standard error</a:t>
+              <a:t>stderr</a:t>
+            </a:r>
+            <a:r>
+              <a:rPr sz="2600" b="0" dirty="0">
+                <a:latin typeface="Cambria"/>
+              </a:rPr>
+              <a:t>	2	standard error</a:t>
             </a:r>
           </a:p>
         </p:txBody>

</xml_diff>